<commit_message>
docs: update presentation guide and slides with corrected symmetric cost numbers
Co-authored-by: Maestro12345-hoax <289761984+Maestro12345-hoax@users.noreply.github.com>
</commit_message>
<xml_diff>
--- a/improved/JLR_Forecasting_Presentation.pptx
+++ b/improved/JLR_Forecasting_Presentation.pptx
@@ -6224,7 +6224,7 @@
                 </a:solidFill>
                 <a:latin typeface="Calibri"/>
               </a:rPr>
-              <a:t>What you'd actually order: forecast + safety stock</a:t>
+              <a:t>Symmetric comparison: same safety stock on both forecasts</a:t>
             </a:r>
           </a:p>
         </p:txBody>
@@ -6307,7 +6307,7 @@
                 </a:solidFill>
                 <a:latin typeface="Calibri"/>
               </a:rPr>
-              <a:t>96.7%</a:t>
+              <a:t>96.6%</a:t>
             </a:r>
           </a:p>
         </p:txBody>
@@ -6346,7 +6346,7 @@
                 </a:solidFill>
                 <a:latin typeface="Calibri"/>
               </a:rPr>
-              <a:t>fill rate (ERP: 77%)</a:t>
+              <a:t>fill rate (ERP+SS: 97.0%)</a:t>
             </a:r>
           </a:p>
         </p:txBody>
@@ -6429,7 +6429,7 @@
                 </a:solidFill>
                 <a:latin typeface="Calibri"/>
               </a:rPr>
-              <a:t>~50%</a:t>
+              <a:t>~1%</a:t>
             </a:r>
           </a:p>
         </p:txBody>
@@ -6468,7 +6468,7 @@
                 </a:solidFill>
                 <a:latin typeface="Calibri"/>
               </a:rPr>
-              <a:t>lower inventory cost</a:t>
+              <a:t>lower cost via better accuracy</a:t>
             </a:r>
           </a:p>
         </p:txBody>
@@ -6590,7 +6590,7 @@
                 </a:solidFill>
                 <a:latin typeface="Calibri"/>
               </a:rPr>
-              <a:t>SKUs under-stocked (ERP: 57%)</a:t>
+              <a:t>SKUs under-stocked (ERP+SS: 2.2%)</a:t>
             </a:r>
           </a:p>
         </p:txBody>
@@ -6691,7 +6691,7 @@
                 </a:solidFill>
                 <a:latin typeface="Calibri"/>
               </a:rPr>
-              <a:t>“Your raw forecast under-predicts more SKUs — isn't that bad?”</a:t>
+              <a:t>"Your raw forecast under-predicts more SKUs -- isn't that bad?"</a:t>
             </a:r>
           </a:p>
           <a:p>
@@ -6723,7 +6723,7 @@
                 </a:solidFill>
                 <a:latin typeface="Calibri"/>
               </a:rPr>
-              <a:t>Yes — which is why you never use the raw point forecast to order. With service-level safety stock added, we hit 96.7% fill rate AND ~50% lower cost. The ERP's over-forecasting is a crude, expensive buffer; our safety stock is precisely sized per SKU.</a:t>
+              <a:t>We apply the same safety-stock formula to both forecasts for a fair comparison. With symmetric buffers, Hybrid+SS achieves 96.6% fill rate (comparable to ERP+SS at 97.0%) at ~1% lower total cost. The real advantage is accuracy: WAPE 38.2% vs 41.0% means less buffer needed for the same service level.</a:t>
             </a:r>
           </a:p>
           <a:p>
@@ -6755,7 +6755,7 @@
                 </a:solidFill>
                 <a:latin typeface="Calibri"/>
               </a:rPr>
-              <a:t>Robust to assumptions: </a:t>
+              <a:t/>
             </a:r>
             <a:r>
               <a:rPr sz="1400" b="0">
@@ -6764,7 +6764,7 @@
                 </a:solidFill>
                 <a:latin typeface="Calibri"/>
               </a:rPr>
-              <a:t>savings hold ~50% across stockout penalties from 1× to 10× unit cost.</a:t>
+              <a:t>Robust to assumptions: savings hold ~1% across stockout penalties from 1x to 10x unit cost. Annualized: $107K-$190K/year.</a:t>
             </a:r>
           </a:p>
         </p:txBody>

</xml_diff>

<commit_message>
fix: restore Dead/No-Demand classification; improve slide 12 framing
Co-authored-by: Maestro12345-hoax <289761984+Maestro12345-hoax@users.noreply.github.com>
</commit_message>
<xml_diff>
--- a/improved/JLR_Forecasting_Presentation.pptx
+++ b/improved/JLR_Forecasting_Presentation.pptx
@@ -6346,7 +6346,7 @@
                 </a:solidFill>
                 <a:latin typeface="Calibri"/>
               </a:rPr>
-              <a:t>fill rate (ERP+SS: 97.0%)</a:t>
+              <a:t>Hybrid+SS fill rate; ERP+SS achieves 97.0%</a:t>
             </a:r>
           </a:p>
         </p:txBody>
@@ -6723,7 +6723,7 @@
                 </a:solidFill>
                 <a:latin typeface="Calibri"/>
               </a:rPr>
-              <a:t>We apply the same safety-stock formula to both forecasts for a fair comparison. With symmetric buffers, Hybrid+SS achieves 96.6% fill rate (comparable to ERP+SS at 97.0%) at ~1% lower total cost. The real advantage is accuracy: WAPE 38.2% vs 41.0% means less buffer needed for the same service level.</a:t>
+              <a:t>Both achieve &gt;96% fill rate; ERP+SS is 0.4pp higher due to over-stocking, but at significantly higher holding cost. We apply the same safety-stock formula to both forecasts for a fair comparison. The real advantage is accuracy: WAPE 38.2% vs 41.0% means less excess inventory for comparable service levels.</a:t>
             </a:r>
           </a:p>
           <a:p>

</xml_diff>